<commit_message>
Add two-profile carrier marketplace, docs-pack PDFs, and label-scan-first intake
Company/carrier profile switcher: the carrier add-in (Cascade demo profile)
sees only Offers/Jobs/Scan — never inventory or values. Offers = Uber-style
acceptance of AI-proposed loads (accepting adds the leg to the company
chain). Vendor label scans: pickup receives the docs pack; a second scan
demos capability-aware vendor auto-substitution ('plan had Redline').
Company Scan reworked to shipping-label + order-number intake (ORD- numbers
seeded). Docs-pack PDF via jspdf: company-approved customs valuation
worksheet, packing slip, BOL, customs checklist — status in-progress until
label scan. Goals footer in Audit. Deck now 12 slides incl. hackathon track
slide (Track 2 primary, Track 1 cross-credit, sponsor-tool wiring plan) and
sample docs-pack PDF in deck/.

Co-Authored-By: Claude Fable 5 <noreply@anthropic.com>
</commit_message>
<xml_diff>
--- a/deck/Transit_Guard_Pitch.pptx
+++ b/deck/Transit_Guard_Pitch.pptx
@@ -16,9 +16,10 @@
     <p:sldId id="264" r:id="rId10"/>
     <p:sldId id="265" r:id="rId11"/>
     <p:sldId id="266" r:id="rId12"/>
+    <p:sldId id="267" r:id="rId13"/>
   </p:sldIdLst>
   <p:notesMasterIdLst>
-    <p:notesMasterId r:id="rId13"/>
+    <p:notesMasterId r:id="rId14"/>
   </p:notesMasterIdLst>
   <p:sldSz cx="12192000" cy="6858000"/>
   <p:notesSz cx="6858000" cy="12192000"/>
@@ -947,7 +948,7 @@
           <a:p>
             <a:r>
               <a:rPr lang="en-US" dirty="0"/>
-              <a:t>Close on the tagline, then switch straight to the live demo.</a:t>
+              <a:t>Track 2 is the primary entry: the product monetizes on both sides of the marketplace and clears the $10 ARR/user bar by orders of magnitude. Track 1 cross-credit comes from the suite economics — the 85% AI-consumption reduction is a real, demoable percentage. Sponsor tools are positioned as wiring, not shipped integrations — be precise about that on stage.</a:t>
             </a:r>
             <a:endParaRPr lang="en-US" dirty="0"/>
           </a:p>
@@ -971,6 +972,94 @@
             <a:fld id="{F7021451-1387-4CA6-816F-3879F97B5CBC}" type="slidenum">
               <a:rPr lang="en-US"/>
               <a:t>11</a:t>
+            </a:fld>
+            <a:endParaRPr lang="en-US"/>
+          </a:p>
+        </p:txBody>
+      </p:sp>
+    </p:spTree>
+    <p:extLst>
+      <p:ext uri="{BB962C8B-B14F-4D97-AF65-F5344CB8AC3E}">
+        <p14:creationId xmlns:p14="http://schemas.microsoft.com/office/powerpoint/2010/main" val="1024086991"/>
+      </p:ext>
+    </p:extLst>
+  </p:cSld>
+  <p:clrMapOvr>
+    <a:masterClrMapping/>
+  </p:clrMapOvr>
+</p:notes>
+</file>
+
+<file path=ppt/notesSlides/notesSlide12.xml><?xml version="1.0" encoding="utf-8"?>
+<p:notes xmlns:a="http://schemas.openxmlformats.org/drawingml/2006/main" xmlns:r="http://schemas.openxmlformats.org/officeDocument/2006/relationships" xmlns:p="http://schemas.openxmlformats.org/presentationml/2006/main">
+  <p:cSld>
+    <p:spTree>
+      <p:nvGrpSpPr>
+        <p:cNvPr id="1" name=""/>
+        <p:cNvGrpSpPr/>
+        <p:nvPr/>
+      </p:nvGrpSpPr>
+      <p:grpSpPr>
+        <a:xfrm>
+          <a:off x="0" y="0"/>
+          <a:ext cx="0" cy="0"/>
+          <a:chOff x="0" y="0"/>
+          <a:chExt cx="0" cy="0"/>
+        </a:xfrm>
+      </p:grpSpPr>
+      <p:sp>
+        <p:nvSpPr>
+          <p:cNvPr id="2" name="Slide Image Placeholder 1"/>
+          <p:cNvSpPr>
+            <a:spLocks noGrp="1" noRot="1" noChangeAspect="1"/>
+          </p:cNvSpPr>
+          <p:nvPr>
+            <p:ph type="sldImg"/>
+          </p:nvPr>
+        </p:nvSpPr>
+        <p:spPr/>
+      </p:sp>
+      <p:sp>
+        <p:nvSpPr>
+          <p:cNvPr id="3" name="Notes Placeholder 2"/>
+          <p:cNvSpPr>
+            <a:spLocks noGrp="1"/>
+          </p:cNvSpPr>
+          <p:nvPr>
+            <p:ph type="body" idx="1"/>
+          </p:nvPr>
+        </p:nvSpPr>
+        <p:spPr/>
+        <p:txBody>
+          <a:bodyPr/>
+          <a:lstStyle/>
+          <a:p>
+            <a:r>
+              <a:rPr lang="en-US" dirty="0"/>
+              <a:t>Close on the tagline, then switch straight to the live demo.</a:t>
+            </a:r>
+            <a:endParaRPr lang="en-US" dirty="0"/>
+          </a:p>
+        </p:txBody>
+      </p:sp>
+      <p:sp>
+        <p:nvSpPr>
+          <p:cNvPr id="4" name="Slide Number Placeholder 3"/>
+          <p:cNvSpPr>
+            <a:spLocks noGrp="1"/>
+          </p:cNvSpPr>
+          <p:nvPr>
+            <p:ph type="sldNum" sz="quarter" idx="10"/>
+          </p:nvPr>
+        </p:nvSpPr>
+        <p:spPr/>
+        <p:txBody>
+          <a:bodyPr/>
+          <a:lstStyle/>
+          <a:p>
+            <a:fld id="{F7021451-1387-4CA6-816F-3879F97B5CBC}" type="slidenum">
+              <a:rPr lang="en-US"/>
+              <a:t>12</a:t>
             </a:fld>
             <a:endParaRPr lang="en-US"/>
           </a:p>
@@ -1299,7 +1388,7 @@
           <a:p>
             <a:r>
               <a:rPr lang="en-US" dirty="0"/>
-              <a:t>Everything on this slide exists and runs today. Two live wow-moments: the AI vendor search overriding a priority that would miss the need-by date, and the OCR reading a trilingual customs worksheet on-device and attaching it to TX-20481.</a:t>
+              <a:t>Everything on this slide exists and runs today. Live wow-moments: the AI route override, the carrier accepting a load and the leg appearing in the company chain, the docs-pack PDF, the label scan flipping docs to received — and the auto vendor substitution ("plan had Redline Haulage").</a:t>
             </a:r>
             <a:endParaRPr lang="en-US" dirty="0"/>
           </a:p>
@@ -3379,6 +3468,668 @@
     <p:bg>
       <p:bgPr>
         <a:solidFill>
+          <a:srgbClr val="FFFFFF"/>
+        </a:solidFill>
+      </p:bgPr>
+    </p:bg>
+    <p:spTree>
+      <p:nvGrpSpPr>
+        <p:cNvPr id="1" name=""/>
+        <p:cNvGrpSpPr/>
+        <p:nvPr/>
+      </p:nvGrpSpPr>
+      <p:grpSpPr>
+        <a:xfrm>
+          <a:off x="0" y="0"/>
+          <a:ext cx="0" cy="0"/>
+          <a:chOff x="0" y="0"/>
+          <a:chExt cx="0" cy="0"/>
+        </a:xfrm>
+      </p:grpSpPr>
+      <p:sp>
+        <p:nvSpPr>
+          <p:cNvPr id="2" name="Text 0"/>
+          <p:cNvSpPr/>
+          <p:nvPr/>
+        </p:nvSpPr>
+        <p:spPr>
+          <a:xfrm>
+            <a:off x="548640" y="411480"/>
+            <a:ext cx="11064240" cy="640080"/>
+          </a:xfrm>
+          <a:prstGeom prst="rect">
+            <a:avLst/>
+          </a:prstGeom>
+          <a:noFill/>
+          <a:ln/>
+        </p:spPr>
+        <p:txBody>
+          <a:bodyPr wrap="square" lIns="0" tIns="0" rIns="0" bIns="0" rtlCol="0" anchor="ctr"/>
+          <a:lstStyle/>
+          <a:p>
+            <a:pPr indent="0" marL="0">
+              <a:buNone/>
+            </a:pPr>
+            <a:r>
+              <a:rPr lang="en-US" sz="3400" b="1" dirty="0">
+                <a:solidFill>
+                  <a:srgbClr val="0F172A"/>
+                </a:solidFill>
+                <a:latin typeface="Calibri" pitchFamily="34" charset="0"/>
+                <a:ea typeface="Calibri" pitchFamily="34" charset="-122"/>
+                <a:cs typeface="Calibri" pitchFamily="34" charset="-120"/>
+              </a:rPr>
+              <a:t>Track 2 — Value of Intelligence.</a:t>
+            </a:r>
+            <a:endParaRPr lang="en-US" sz="3400" dirty="0"/>
+          </a:p>
+        </p:txBody>
+      </p:sp>
+      <p:sp>
+        <p:nvSpPr>
+          <p:cNvPr id="3" name="Text 1"/>
+          <p:cNvSpPr/>
+          <p:nvPr/>
+        </p:nvSpPr>
+        <p:spPr>
+          <a:xfrm>
+            <a:off x="548640" y="1078992"/>
+            <a:ext cx="10881360" cy="411480"/>
+          </a:xfrm>
+          <a:prstGeom prst="rect">
+            <a:avLst/>
+          </a:prstGeom>
+          <a:noFill/>
+          <a:ln/>
+        </p:spPr>
+        <p:txBody>
+          <a:bodyPr wrap="square" lIns="0" tIns="0" rIns="0" bIns="0" rtlCol="0" anchor="ctr"/>
+          <a:lstStyle/>
+          <a:p>
+            <a:pPr indent="0" marL="0">
+              <a:buNone/>
+            </a:pPr>
+            <a:r>
+              <a:rPr lang="en-US" sz="1400" dirty="0">
+                <a:solidFill>
+                  <a:srgbClr val="475569"/>
+                </a:solidFill>
+                <a:latin typeface="Calibri" pitchFamily="34" charset="0"/>
+                <a:ea typeface="Calibri" pitchFamily="34" charset="-122"/>
+                <a:cs typeface="Calibri" pitchFamily="34" charset="-120"/>
+              </a:rPr>
+              <a:t>Real willingness-to-pay, demonstrated in the demo — with Track 1 economics built into the suite’s DNA.</a:t>
+            </a:r>
+            <a:endParaRPr lang="en-US" sz="1400" dirty="0"/>
+          </a:p>
+        </p:txBody>
+      </p:sp>
+      <p:sp>
+        <p:nvSpPr>
+          <p:cNvPr id="4" name="Shape 2"/>
+          <p:cNvSpPr/>
+          <p:nvPr/>
+        </p:nvSpPr>
+        <p:spPr>
+          <a:xfrm>
+            <a:off x="548640" y="1691640"/>
+            <a:ext cx="5577840" cy="2743200"/>
+          </a:xfrm>
+          <a:prstGeom prst="roundRect">
+            <a:avLst>
+              <a:gd name="adj" fmla="val 3333"/>
+            </a:avLst>
+          </a:prstGeom>
+          <a:solidFill>
+            <a:srgbClr val="059669"/>
+          </a:solidFill>
+          <a:ln w="12700">
+            <a:solidFill>
+              <a:srgbClr val="E2E8F0"/>
+            </a:solidFill>
+            <a:prstDash val="solid"/>
+          </a:ln>
+          <a:effectLst>
+            <a:outerShdw sx="100000" sy="100000" kx="0" ky="0" algn="bl" rotWithShape="0" blurRad="88900" dist="25400" dir="5400000">
+              <a:srgbClr val="CBD5E1">
+                <a:alpha val="40000"/>
+              </a:srgbClr>
+            </a:outerShdw>
+          </a:effectLst>
+        </p:spPr>
+      </p:sp>
+      <p:sp>
+        <p:nvSpPr>
+          <p:cNvPr id="5" name="Text 3"/>
+          <p:cNvSpPr/>
+          <p:nvPr/>
+        </p:nvSpPr>
+        <p:spPr>
+          <a:xfrm>
+            <a:off x="868680" y="1920240"/>
+            <a:ext cx="5029200" cy="320040"/>
+          </a:xfrm>
+          <a:prstGeom prst="rect">
+            <a:avLst/>
+          </a:prstGeom>
+          <a:noFill/>
+          <a:ln/>
+        </p:spPr>
+        <p:txBody>
+          <a:bodyPr wrap="square" lIns="0" tIns="0" rIns="0" bIns="0" rtlCol="0" anchor="ctr"/>
+          <a:lstStyle/>
+          <a:p>
+            <a:pPr indent="0" marL="0">
+              <a:buNone/>
+            </a:pPr>
+            <a:r>
+              <a:rPr lang="en-US" sz="1200" b="1" spc="100" kern="0" dirty="0">
+                <a:solidFill>
+                  <a:srgbClr val="FFFFFF"/>
+                </a:solidFill>
+                <a:latin typeface="Calibri" pitchFamily="34" charset="0"/>
+                <a:ea typeface="Calibri" pitchFamily="34" charset="-122"/>
+                <a:cs typeface="Calibri" pitchFamily="34" charset="-120"/>
+              </a:rPr>
+              <a:t>PRIMARY · TRACK 2 — VALUE OF INTELLIGENCE</a:t>
+            </a:r>
+            <a:endParaRPr lang="en-US" sz="1200" dirty="0"/>
+          </a:p>
+        </p:txBody>
+      </p:sp>
+      <p:sp>
+        <p:nvSpPr>
+          <p:cNvPr id="6" name="Text 4"/>
+          <p:cNvSpPr/>
+          <p:nvPr/>
+        </p:nvSpPr>
+        <p:spPr>
+          <a:xfrm>
+            <a:off x="868680" y="2331720"/>
+            <a:ext cx="4983480" cy="1965960"/>
+          </a:xfrm>
+          <a:prstGeom prst="rect">
+            <a:avLst/>
+          </a:prstGeom>
+          <a:noFill/>
+          <a:ln/>
+        </p:spPr>
+        <p:txBody>
+          <a:bodyPr wrap="square" lIns="0" tIns="0" rIns="0" bIns="0" rtlCol="0" anchor="ctr"/>
+          <a:lstStyle/>
+          <a:p>
+            <a:pPr marL="342900" indent="-342900">
+              <a:spcAft>
+                <a:spcPts val="600"/>
+              </a:spcAft>
+              <a:buSzPct val="100000"/>
+              <a:buChar char="•"/>
+            </a:pPr>
+            <a:r>
+              <a:rPr lang="en-US" sz="1150" dirty="0">
+                <a:solidFill>
+                  <a:srgbClr val="FFFFFF"/>
+                </a:solidFill>
+                <a:latin typeface="Calibri" pitchFamily="34" charset="0"/>
+                <a:ea typeface="Calibri" pitchFamily="34" charset="-122"/>
+                <a:cs typeface="Calibri" pitchFamily="34" charset="-120"/>
+              </a:rPr>
+              <a:t>Company side: $12K/yr ACV — the controller buys audit-ready revenue recognition (SOM model: 4,000 exporters × $12K).</a:t>
+            </a:r>
+            <a:endParaRPr lang="en-US" sz="1150" dirty="0"/>
+          </a:p>
+          <a:p>
+            <a:pPr marL="342900" indent="-342900">
+              <a:spcAft>
+                <a:spcPts val="600"/>
+              </a:spcAft>
+              <a:buSzPct val="100000"/>
+              <a:buChar char="•"/>
+            </a:pPr>
+            <a:r>
+              <a:rPr lang="en-US" sz="1150" dirty="0">
+                <a:solidFill>
+                  <a:srgbClr val="FFFFFF"/>
+                </a:solidFill>
+                <a:latin typeface="Calibri" pitchFamily="34" charset="0"/>
+                <a:ea typeface="Calibri" pitchFamily="34" charset="-122"/>
+                <a:cs typeface="Calibri" pitchFamily="34" charset="-120"/>
+              </a:rPr>
+              <a:t>Carrier side: free add-in + ~2% take rate per accepted load — $29 on the $1,450 demo load, marketplace economics.</a:t>
+            </a:r>
+            <a:endParaRPr lang="en-US" sz="1150" dirty="0"/>
+          </a:p>
+          <a:p>
+            <a:pPr marL="342900" indent="-342900">
+              <a:buSzPct val="100000"/>
+              <a:buChar char="•"/>
+            </a:pPr>
+            <a:r>
+              <a:rPr lang="en-US" sz="1150" dirty="0">
+                <a:solidFill>
+                  <a:srgbClr val="FFFFFF"/>
+                </a:solidFill>
+                <a:latin typeface="Calibri" pitchFamily="34" charset="0"/>
+                <a:ea typeface="Calibri" pitchFamily="34" charset="-122"/>
+                <a:cs typeface="Calibri" pitchFamily="34" charset="-120"/>
+              </a:rPr>
+              <a:t>The $10 ARR-per-user bar is cleared ~1,000× per seat. Willingness-to-pay is the demo itself: the $1M flag no CFO wants to miss.</a:t>
+            </a:r>
+            <a:endParaRPr lang="en-US" sz="1150" dirty="0"/>
+          </a:p>
+        </p:txBody>
+      </p:sp>
+      <p:sp>
+        <p:nvSpPr>
+          <p:cNvPr id="7" name="Shape 5"/>
+          <p:cNvSpPr/>
+          <p:nvPr/>
+        </p:nvSpPr>
+        <p:spPr>
+          <a:xfrm>
+            <a:off x="6400800" y="1691640"/>
+            <a:ext cx="5212080" cy="2743200"/>
+          </a:xfrm>
+          <a:prstGeom prst="roundRect">
+            <a:avLst>
+              <a:gd name="adj" fmla="val 3333"/>
+            </a:avLst>
+          </a:prstGeom>
+          <a:solidFill>
+            <a:srgbClr val="F8FAFC"/>
+          </a:solidFill>
+          <a:ln w="12700">
+            <a:solidFill>
+              <a:srgbClr val="E2E8F0"/>
+            </a:solidFill>
+            <a:prstDash val="solid"/>
+          </a:ln>
+          <a:effectLst>
+            <a:outerShdw sx="100000" sy="100000" kx="0" ky="0" algn="bl" rotWithShape="0" blurRad="88900" dist="25400" dir="5400000">
+              <a:srgbClr val="CBD5E1">
+                <a:alpha val="40000"/>
+              </a:srgbClr>
+            </a:outerShdw>
+          </a:effectLst>
+        </p:spPr>
+      </p:sp>
+      <p:sp>
+        <p:nvSpPr>
+          <p:cNvPr id="8" name="Text 6"/>
+          <p:cNvSpPr/>
+          <p:nvPr/>
+        </p:nvSpPr>
+        <p:spPr>
+          <a:xfrm>
+            <a:off x="6720840" y="1920240"/>
+            <a:ext cx="4663440" cy="320040"/>
+          </a:xfrm>
+          <a:prstGeom prst="rect">
+            <a:avLst/>
+          </a:prstGeom>
+          <a:noFill/>
+          <a:ln/>
+        </p:spPr>
+        <p:txBody>
+          <a:bodyPr wrap="square" lIns="0" tIns="0" rIns="0" bIns="0" rtlCol="0" anchor="ctr"/>
+          <a:lstStyle/>
+          <a:p>
+            <a:pPr indent="0" marL="0">
+              <a:buNone/>
+            </a:pPr>
+            <a:r>
+              <a:rPr lang="en-US" sz="1200" b="1" spc="100" kern="0" dirty="0">
+                <a:solidFill>
+                  <a:srgbClr val="0F766E"/>
+                </a:solidFill>
+                <a:latin typeface="Calibri" pitchFamily="34" charset="0"/>
+                <a:ea typeface="Calibri" pitchFamily="34" charset="-122"/>
+                <a:cs typeface="Calibri" pitchFamily="34" charset="-120"/>
+              </a:rPr>
+              <a:t>CROSS-CREDIT · TRACK 1 — COST OF INTELLIGENCE</a:t>
+            </a:r>
+            <a:endParaRPr lang="en-US" sz="1200" dirty="0"/>
+          </a:p>
+        </p:txBody>
+      </p:sp>
+      <p:sp>
+        <p:nvSpPr>
+          <p:cNvPr id="9" name="Text 7"/>
+          <p:cNvSpPr/>
+          <p:nvPr/>
+        </p:nvSpPr>
+        <p:spPr>
+          <a:xfrm>
+            <a:off x="6720840" y="2286000"/>
+            <a:ext cx="4663440" cy="365760"/>
+          </a:xfrm>
+          <a:prstGeom prst="rect">
+            <a:avLst/>
+          </a:prstGeom>
+          <a:noFill/>
+          <a:ln/>
+        </p:spPr>
+        <p:txBody>
+          <a:bodyPr wrap="square" lIns="0" tIns="0" rIns="0" bIns="0" rtlCol="0" anchor="ctr"/>
+          <a:lstStyle/>
+          <a:p>
+            <a:pPr indent="0" marL="0">
+              <a:buNone/>
+            </a:pPr>
+            <a:r>
+              <a:rPr lang="en-US" sz="1300" b="1" i="1" dirty="0">
+                <a:solidFill>
+                  <a:srgbClr val="0F172A"/>
+                </a:solidFill>
+                <a:latin typeface="Calibri" pitchFamily="34" charset="0"/>
+                <a:ea typeface="Calibri" pitchFamily="34" charset="-122"/>
+                <a:cs typeface="Calibri" pitchFamily="34" charset="-120"/>
+              </a:rPr>
+              <a:t>“Materiality determines AI spend.”</a:t>
+            </a:r>
+            <a:endParaRPr lang="en-US" sz="1300" dirty="0"/>
+          </a:p>
+        </p:txBody>
+      </p:sp>
+      <p:sp>
+        <p:nvSpPr>
+          <p:cNvPr id="10" name="Text 8"/>
+          <p:cNvSpPr/>
+          <p:nvPr/>
+        </p:nvSpPr>
+        <p:spPr>
+          <a:xfrm>
+            <a:off x="6720840" y="2697480"/>
+            <a:ext cx="4709160" cy="1645920"/>
+          </a:xfrm>
+          <a:prstGeom prst="rect">
+            <a:avLst/>
+          </a:prstGeom>
+          <a:noFill/>
+          <a:ln/>
+        </p:spPr>
+        <p:txBody>
+          <a:bodyPr wrap="square" lIns="0" tIns="0" rIns="0" bIns="0" rtlCol="0" anchor="ctr"/>
+          <a:lstStyle/>
+          <a:p>
+            <a:pPr marL="342900" indent="-342900">
+              <a:spcAft>
+                <a:spcPts val="600"/>
+              </a:spcAft>
+              <a:buSzPct val="100000"/>
+              <a:buChar char="•"/>
+            </a:pPr>
+            <a:r>
+              <a:rPr lang="en-US" sz="1150" dirty="0">
+                <a:solidFill>
+                  <a:srgbClr val="475569"/>
+                </a:solidFill>
+                <a:latin typeface="Calibri" pitchFamily="34" charset="0"/>
+                <a:ea typeface="Calibri" pitchFamily="34" charset="-122"/>
+                <a:cs typeface="Calibri" pitchFamily="34" charset="-120"/>
+              </a:rPr>
+              <a:t>The Guard suite routes AI attention by materiality: rules clear the bulk, economy AI screens the middle, premium AI investigates only material exceptions like the $1M lane.</a:t>
+            </a:r>
+            <a:endParaRPr lang="en-US" sz="1150" dirty="0"/>
+          </a:p>
+          <a:p>
+            <a:pPr marL="342900" indent="-342900">
+              <a:buSzPct val="100000"/>
+              <a:buChar char="•"/>
+            </a:pPr>
+            <a:r>
+              <a:rPr lang="en-US" sz="1150" dirty="0">
+                <a:solidFill>
+                  <a:srgbClr val="475569"/>
+                </a:solidFill>
+                <a:latin typeface="Calibri" pitchFamily="34" charset="0"/>
+                <a:ea typeface="Calibri" pitchFamily="34" charset="-122"/>
+                <a:cs typeface="Calibri" pitchFamily="34" charset="-120"/>
+              </a:rPr>
+              <a:t>Suite result shown live: 85% less AI consumption — 410K → 63K tokens, $1.84 → $0.28 per close. A real percentage cost reduction, in the demo.</a:t>
+            </a:r>
+            <a:endParaRPr lang="en-US" sz="1150" dirty="0"/>
+          </a:p>
+        </p:txBody>
+      </p:sp>
+      <p:sp>
+        <p:nvSpPr>
+          <p:cNvPr id="11" name="Shape 9"/>
+          <p:cNvSpPr/>
+          <p:nvPr/>
+        </p:nvSpPr>
+        <p:spPr>
+          <a:xfrm>
+            <a:off x="548640" y="4709160"/>
+            <a:ext cx="5577840" cy="1463040"/>
+          </a:xfrm>
+          <a:prstGeom prst="roundRect">
+            <a:avLst>
+              <a:gd name="adj" fmla="val 6250"/>
+            </a:avLst>
+          </a:prstGeom>
+          <a:solidFill>
+            <a:srgbClr val="F8FAFC"/>
+          </a:solidFill>
+          <a:ln w="12700">
+            <a:solidFill>
+              <a:srgbClr val="E2E8F0"/>
+            </a:solidFill>
+            <a:prstDash val="solid"/>
+          </a:ln>
+          <a:effectLst>
+            <a:outerShdw sx="100000" sy="100000" kx="0" ky="0" algn="bl" rotWithShape="0" blurRad="88900" dist="25400" dir="5400000">
+              <a:srgbClr val="CBD5E1">
+                <a:alpha val="40000"/>
+              </a:srgbClr>
+            </a:outerShdw>
+          </a:effectLst>
+        </p:spPr>
+      </p:sp>
+      <p:sp>
+        <p:nvSpPr>
+          <p:cNvPr id="12" name="Text 10"/>
+          <p:cNvSpPr/>
+          <p:nvPr/>
+        </p:nvSpPr>
+        <p:spPr>
+          <a:xfrm>
+            <a:off x="868680" y="4919472"/>
+            <a:ext cx="5029200" cy="320040"/>
+          </a:xfrm>
+          <a:prstGeom prst="rect">
+            <a:avLst/>
+          </a:prstGeom>
+          <a:noFill/>
+          <a:ln/>
+        </p:spPr>
+        <p:txBody>
+          <a:bodyPr wrap="square" lIns="0" tIns="0" rIns="0" bIns="0" rtlCol="0" anchor="ctr"/>
+          <a:lstStyle/>
+          <a:p>
+            <a:pPr indent="0" marL="0">
+              <a:buNone/>
+            </a:pPr>
+            <a:r>
+              <a:rPr lang="en-US" sz="1300" b="1" dirty="0">
+                <a:solidFill>
+                  <a:srgbClr val="059669"/>
+                </a:solidFill>
+                <a:latin typeface="Calibri" pitchFamily="34" charset="0"/>
+                <a:ea typeface="Calibri" pitchFamily="34" charset="-122"/>
+                <a:cs typeface="Calibri" pitchFamily="34" charset="-120"/>
+              </a:rPr>
+              <a:t>Optional sponsor tools — wiring plan (demo setup)</a:t>
+            </a:r>
+            <a:endParaRPr lang="en-US" sz="1300" dirty="0"/>
+          </a:p>
+        </p:txBody>
+      </p:sp>
+      <p:sp>
+        <p:nvSpPr>
+          <p:cNvPr id="13" name="Text 11"/>
+          <p:cNvSpPr/>
+          <p:nvPr/>
+        </p:nvSpPr>
+        <p:spPr>
+          <a:xfrm>
+            <a:off x="868680" y="5257800"/>
+            <a:ext cx="5029200" cy="868680"/>
+          </a:xfrm>
+          <a:prstGeom prst="rect">
+            <a:avLst/>
+          </a:prstGeom>
+          <a:noFill/>
+          <a:ln/>
+        </p:spPr>
+        <p:txBody>
+          <a:bodyPr wrap="square" lIns="0" tIns="0" rIns="0" bIns="0" rtlCol="0" anchor="ctr"/>
+          <a:lstStyle/>
+          <a:p>
+            <a:pPr indent="0" marL="0">
+              <a:buNone/>
+            </a:pPr>
+            <a:r>
+              <a:rPr lang="en-US" sz="1050" dirty="0">
+                <a:solidFill>
+                  <a:srgbClr val="475569"/>
+                </a:solidFill>
+                <a:latin typeface="Calibri" pitchFamily="34" charset="0"/>
+                <a:ea typeface="Calibri" pitchFamily="34" charset="-122"/>
+                <a:cs typeface="Calibri" pitchFamily="34" charset="-120"/>
+              </a:rPr>
+              <a:t>Evermind → persistent agent memory of vendor performance, feeding route rankings and on-time scores. Voice Cursor → hands-free custody logging at the dock (“hand-off to Cascade — signed”). Both drop into hooks that already exist: the route ranker and the scan intake.</a:t>
+            </a:r>
+            <a:endParaRPr lang="en-US" sz="1050" dirty="0"/>
+          </a:p>
+        </p:txBody>
+      </p:sp>
+      <p:sp>
+        <p:nvSpPr>
+          <p:cNvPr id="14" name="Shape 12"/>
+          <p:cNvSpPr/>
+          <p:nvPr/>
+        </p:nvSpPr>
+        <p:spPr>
+          <a:xfrm>
+            <a:off x="6400800" y="4709160"/>
+            <a:ext cx="5212080" cy="1463040"/>
+          </a:xfrm>
+          <a:prstGeom prst="roundRect">
+            <a:avLst>
+              <a:gd name="adj" fmla="val 6250"/>
+            </a:avLst>
+          </a:prstGeom>
+          <a:solidFill>
+            <a:srgbClr val="0F172A"/>
+          </a:solidFill>
+          <a:ln w="12700">
+            <a:solidFill>
+              <a:srgbClr val="E2E8F0"/>
+            </a:solidFill>
+            <a:prstDash val="solid"/>
+          </a:ln>
+          <a:effectLst>
+            <a:outerShdw sx="100000" sy="100000" kx="0" ky="0" algn="bl" rotWithShape="0" blurRad="88900" dist="25400" dir="5400000">
+              <a:srgbClr val="CBD5E1">
+                <a:alpha val="40000"/>
+              </a:srgbClr>
+            </a:outerShdw>
+          </a:effectLst>
+        </p:spPr>
+      </p:sp>
+      <p:sp>
+        <p:nvSpPr>
+          <p:cNvPr id="15" name="Text 13"/>
+          <p:cNvSpPr/>
+          <p:nvPr/>
+        </p:nvSpPr>
+        <p:spPr>
+          <a:xfrm>
+            <a:off x="6720840" y="4919472"/>
+            <a:ext cx="4663440" cy="320040"/>
+          </a:xfrm>
+          <a:prstGeom prst="rect">
+            <a:avLst/>
+          </a:prstGeom>
+          <a:noFill/>
+          <a:ln/>
+        </p:spPr>
+        <p:txBody>
+          <a:bodyPr wrap="square" lIns="0" tIns="0" rIns="0" bIns="0" rtlCol="0" anchor="ctr"/>
+          <a:lstStyle/>
+          <a:p>
+            <a:pPr indent="0" marL="0">
+              <a:buNone/>
+            </a:pPr>
+            <a:r>
+              <a:rPr lang="en-US" sz="1300" b="1" dirty="0">
+                <a:solidFill>
+                  <a:srgbClr val="34D399"/>
+                </a:solidFill>
+                <a:latin typeface="Calibri" pitchFamily="34" charset="0"/>
+                <a:ea typeface="Calibri" pitchFamily="34" charset="-122"/>
+                <a:cs typeface="Calibri" pitchFamily="34" charset="-120"/>
+              </a:rPr>
+              <a:t>The 3-minute demo</a:t>
+            </a:r>
+            <a:endParaRPr lang="en-US" sz="1300" dirty="0"/>
+          </a:p>
+        </p:txBody>
+      </p:sp>
+      <p:sp>
+        <p:nvSpPr>
+          <p:cNvPr id="16" name="Text 14"/>
+          <p:cNvSpPr/>
+          <p:nvPr/>
+        </p:nvSpPr>
+        <p:spPr>
+          <a:xfrm>
+            <a:off x="6720840" y="5257800"/>
+            <a:ext cx="4709160" cy="868680"/>
+          </a:xfrm>
+          <a:prstGeom prst="rect">
+            <a:avLst/>
+          </a:prstGeom>
+          <a:noFill/>
+          <a:ln/>
+        </p:spPr>
+        <p:txBody>
+          <a:bodyPr wrap="square" lIns="0" tIns="0" rIns="0" bIns="0" rtlCol="0" anchor="ctr"/>
+          <a:lstStyle/>
+          <a:p>
+            <a:pPr indent="0" marL="0">
+              <a:buNone/>
+            </a:pPr>
+            <a:r>
+              <a:rPr lang="en-US" sz="1050" dirty="0">
+                <a:solidFill>
+                  <a:srgbClr val="CBD5E1"/>
+                </a:solidFill>
+                <a:latin typeface="Calibri" pitchFamily="34" charset="0"/>
+                <a:ea typeface="Calibri" pitchFamily="34" charset="-122"/>
+                <a:cs typeface="Calibri" pitchFamily="34" charset="-120"/>
+              </a:rPr>
+              <a:t>Label scan → AI route + need-by override → carrier accepts Uber-style → docs-pack PDF → label scan flips it to received → the $1M FOB-destination flag. Submit by 3:55 — the deadline docks points.</a:t>
+            </a:r>
+            <a:endParaRPr lang="en-US" sz="1050" dirty="0"/>
+          </a:p>
+        </p:txBody>
+      </p:sp>
+    </p:spTree>
+  </p:cSld>
+  <p:clrMapOvr>
+    <a:masterClrMapping/>
+  </p:clrMapOvr>
+</p:sld>
+</file>
+
+<file path=ppt/slides/slide12.xml><?xml version="1.0" encoding="utf-8"?>
+<p:sld xmlns:a="http://schemas.openxmlformats.org/drawingml/2006/main" xmlns:r="http://schemas.openxmlformats.org/officeDocument/2006/relationships" xmlns:p="http://schemas.openxmlformats.org/presentationml/2006/main">
+  <p:cSld name="Slide 12">
+    <p:bg>
+      <p:bgPr>
+        <a:solidFill>
           <a:srgbClr val="0F172A"/>
         </a:solidFill>
       </p:bgPr>
@@ -3684,6 +4435,45 @@
         <p:spPr>
           <a:xfrm>
             <a:off x="822960" y="4709160"/>
+            <a:ext cx="10515600" cy="411480"/>
+          </a:xfrm>
+          <a:prstGeom prst="rect">
+            <a:avLst/>
+          </a:prstGeom>
+          <a:noFill/>
+          <a:ln/>
+        </p:spPr>
+        <p:txBody>
+          <a:bodyPr wrap="square" lIns="0" tIns="0" rIns="0" bIns="0" rtlCol="0" anchor="ctr"/>
+          <a:lstStyle/>
+          <a:p>
+            <a:pPr indent="0" marL="0">
+              <a:buNone/>
+            </a:pPr>
+            <a:r>
+              <a:rPr lang="en-US" sz="1350" dirty="0">
+                <a:solidFill>
+                  <a:srgbClr val="CBD5E1"/>
+                </a:solidFill>
+                <a:latin typeface="Calibri" pitchFamily="34" charset="0"/>
+                <a:ea typeface="Calibri" pitchFamily="34" charset="-122"/>
+                <a:cs typeface="Calibri" pitchFamily="34" charset="-120"/>
+              </a:rPr>
+              <a:t>Transparency for tax planning · delivery dates for revenue recognition · audit-ready documentation · stock planning · returns management.</a:t>
+            </a:r>
+            <a:endParaRPr lang="en-US" sz="1350" dirty="0"/>
+          </a:p>
+        </p:txBody>
+      </p:sp>
+      <p:sp>
+        <p:nvSpPr>
+          <p:cNvPr id="14" name="Text 12"/>
+          <p:cNvSpPr/>
+          <p:nvPr/>
+        </p:nvSpPr>
+        <p:spPr>
+          <a:xfrm>
+            <a:off x="822960" y="5212080"/>
             <a:ext cx="10515600" cy="365760"/>
           </a:xfrm>
           <a:prstGeom prst="rect">
@@ -3700,7 +4490,7 @@
               <a:buNone/>
             </a:pPr>
             <a:r>
-              <a:rPr lang="en-US" sz="1300" dirty="0">
+              <a:rPr lang="en-US" sz="1200" dirty="0">
                 <a:solidFill>
                   <a:srgbClr val="94A3B8"/>
                 </a:solidFill>
@@ -3710,7 +4500,7 @@
               </a:rPr>
               <a:t>Live demo: localhost:5174 · All data synthetic · Thank you</a:t>
             </a:r>
-            <a:endParaRPr lang="en-US" sz="1300" dirty="0"/>
+            <a:endParaRPr lang="en-US" sz="1200" dirty="0"/>
           </a:p>
         </p:txBody>
       </p:sp>
@@ -7962,7 +8752,7 @@
                 <a:ea typeface="Calibri" pitchFamily="34" charset="-122"/>
                 <a:cs typeface="Calibri" pitchFamily="34" charset="-120"/>
               </a:rPr>
-              <a:t>Simulated barcode scan + the “why is it leaving?” intake.</a:t>
+              <a:t>Shipping-label scan + order number + the “why is it leaving?” intake.</a:t>
             </a:r>
             <a:endParaRPr lang="en-US" sz="1050" dirty="0"/>
           </a:p>
@@ -8854,7 +9644,7 @@
                 <a:ea typeface="Calibri" pitchFamily="34" charset="-122"/>
                 <a:cs typeface="Calibri" pitchFamily="34" charset="-120"/>
               </a:rPr>
-              <a:t>Live at localhost:5174 — a phone-frame web app with presenter notes on screen. Multilingual UI (English · Spanish · French).  </a:t>
+              <a:t>Two profiles in one app: company ops and the carrier add-in. Carriers accept AI-proposed loads Uber-style; a shipping-label scan receives the docs pack — or auto-updates the vendor when a different carrier takes the load.  </a:t>
             </a:r>
             <a:endParaRPr lang="en-US" sz="1150" dirty="0"/>
           </a:p>
@@ -8871,7 +9661,7 @@
                 <a:ea typeface="Calibri" pitchFamily="34" charset="-122"/>
                 <a:cs typeface="Calibri" pitchFamily="34" charset="-120"/>
               </a:rPr>
-              <a:t>Partner carrier apps plug in via the Transit Guard API and scan EU hand-off QRs — the transaction ID never breaks between systems.  </a:t>
+              <a:t>Company-approved docs pack printed as PDF from the app: customs valuation worksheet · packing slip · bill of lading · destination customs checklist.  </a:t>
             </a:r>
             <a:endParaRPr lang="en-US" sz="1150" dirty="0"/>
           </a:p>
@@ -8888,7 +9678,7 @@
                 <a:ea typeface="Calibri" pitchFamily="34" charset="-122"/>
                 <a:cs typeface="Calibri" pitchFamily="34" charset="-120"/>
               </a:rPr>
-              <a:t>On-device multilingual OCR (Tesseract) reads a customs document and files it to the right transaction — no backend, no API keys, demo-safe offline.</a:t>
+              <a:t>Live at localhost:5174 — EN/ES/FR, on-device OCR, EU hand-off QR. No backend, no API keys, demo-safe offline.</a:t>
             </a:r>
             <a:endParaRPr lang="en-US" sz="1150" dirty="0"/>
           </a:p>

</xml_diff>

<commit_message>
Add agent rerouting, per-stage docs access, and web/mobile view toggle
Declining an offer now auto-reroutes: the agent re-matches the load to the
alternate carrier and the leg lands in the company chain with a reroute
note. Every custody-chain stage gets a one-click docs-pack PDF button
(shipping/receiving docs, customs docs, BOL, valuation worksheet). New
web/mobile toggle renders the same app as a desktop web layout — the
responsive web-app story for vendors viewing any stage. Deterministic leg
IDs replace the impure legSeq counter (fixes StrictMode duplicate-key
warning). Deck banner updated for reroute/per-stage-docs/web+mobile.

Co-Authored-By: Claude Fable 5 <noreply@anthropic.com>
</commit_message>
<xml_diff>
--- a/deck/Transit_Guard_Pitch.pptx
+++ b/deck/Transit_Guard_Pitch.pptx
@@ -1388,7 +1388,7 @@
           <a:p>
             <a:r>
               <a:rPr lang="en-US" dirty="0"/>
-              <a:t>Everything on this slide exists and runs today. Live wow-moments: the AI route override, the carrier accepting a load and the leg appearing in the company chain, the docs-pack PDF, the label scan flipping docs to received — and the auto vendor substitution ("plan had Redline Haulage").</a:t>
+              <a:t>Everything on this slide exists and runs today. Live wow-moments: the AI route override; the carrier DECLINING a load and the agent rerouting it to Redline in seconds (Uber-style availability matching); one-click per-stage documents; the label scan flipping docs to received; the auto vendor substitution. Toggle the 📱/🖥️ switch above the demo to show the same app as desktop web and mobile.</a:t>
             </a:r>
             <a:endParaRPr lang="en-US" dirty="0"/>
           </a:p>
@@ -9644,7 +9644,7 @@
                 <a:ea typeface="Calibri" pitchFamily="34" charset="-122"/>
                 <a:cs typeface="Calibri" pitchFamily="34" charset="-120"/>
               </a:rPr>
-              <a:t>Two profiles in one app: company ops and the carrier add-in. Carriers accept AI-proposed loads Uber-style; a shipping-label scan receives the docs pack — or auto-updates the vendor when a different carrier takes the load.  </a:t>
+              <a:t>Route and reroute like a rideshare: priorities (fastest · balanced · lowest cost) drive the agent — when a carrier declines, it re-matches the load and the chain still gets its leg. Two profiles: company ops + the carrier add-in, which sees only the shipping transaction.  </a:t>
             </a:r>
             <a:endParaRPr lang="en-US" sz="1150" dirty="0"/>
           </a:p>
@@ -9661,7 +9661,7 @@
                 <a:ea typeface="Calibri" pitchFamily="34" charset="-122"/>
                 <a:cs typeface="Calibri" pitchFamily="34" charset="-120"/>
               </a:rPr>
-              <a:t>Company-approved docs pack printed as PDF from the app: customs valuation worksheet · packing slip · bill of lading · destination customs checklist.  </a:t>
+              <a:t>Every routing stage is clickable — one tap on any stopping point prints its documents as PDF: shipping &amp; receiving docs, customs documents, bill of lading, valuation worksheet.  </a:t>
             </a:r>
             <a:endParaRPr lang="en-US" sz="1150" dirty="0"/>
           </a:p>
@@ -9678,7 +9678,7 @@
                 <a:ea typeface="Calibri" pitchFamily="34" charset="-122"/>
                 <a:cs typeface="Calibri" pitchFamily="34" charset="-120"/>
               </a:rPr>
-              <a:t>Live at localhost:5174 — EN/ES/FR, on-device OCR, EU hand-off QR. No backend, no API keys, demo-safe offline.</a:t>
+              <a:t>Responsive web app with a mobile view — vendors open any stage they need from a browser. EN/ES/FR, on-device OCR, EU hand-off QR. No backend, demo-safe offline.</a:t>
             </a:r>
             <a:endParaRPr lang="en-US" sz="1150" dirty="0"/>
           </a:p>

</xml_diff>